<commit_message>
Add SURETY prototype service and deployment config
New:
- prototype/: FastAPI policy enforcement service with OPA integration,
  Redis token buckets, circuit breaker, and operator console UI
- prototype/static/index.html: Live operator dashboard
- prototype/test_client.py: Integration test client
- prototype/breaker_demo.sh: Circuit breaker demo script
- prototype/Dockerfile: Container build for deployment
- prototype/DEPLOY.md: Deployment guide (Render, Docker, local)
- render.yaml: Render.com blueprint for free-tier deployment

Updated:
- README.md: Expanded documentation
- docs/PROJECT_DESCRIPTION.md: Updated project description
- .gitignore: Added Python/prototype exclusions
- appendix/README.txt: Updated appendix index
- deck/: Updated Round 1 presentation
</commit_message>
<xml_diff>
--- a/deck/SURETY_Round1_Deck.pptx
+++ b/deck/SURETY_Round1_Deck.pptx
@@ -1131,7 +1131,7 @@
           <a:p>
             <a:r>
               <a:rPr lang="en-US" dirty="0"/>
-              <a:t>Every task the judges asked for is addressed explicitly: permissions, dynamic caps, revocation, dashboard, testing. The right-hand column is the commitment: each one is demonstrated live, not described.</a:t>
+              <a:t>Every task the judges asked for is addressed explicitly: permissions, dynamic caps, revocation, dashboard, testing. The right-hand column is the commitment: each one is demonstrated live, not described. One of them is already built: revocation ships as a working POST /breaker endpoint in the Round 1 prototype, with agent, class and fleet scopes, and every trip written to the hash-chained audit ledger. If you want, we can pull the fleet breaker on this call.</a:t>
             </a:r>
             <a:endParaRPr lang="en-US" dirty="0"/>
           </a:p>
@@ -8832,6 +8832,99 @@
         </p:nvSpPr>
         <p:spPr>
           <a:xfrm>
+            <a:off x="9555480" y="4206240"/>
+            <a:ext cx="1993392" cy="192024"/>
+          </a:xfrm>
+          <a:prstGeom prst="roundRect">
+            <a:avLst>
+              <a:gd name="adj" fmla="val 14286"/>
+            </a:avLst>
+          </a:prstGeom>
+          <a:solidFill>
+            <a:srgbClr val="C8A951">
+              <a:alpha val="12000"/>
+            </a:srgbClr>
+          </a:solidFill>
+          <a:ln w="9525">
+            <a:solidFill>
+              <a:srgbClr val="C8A951"/>
+            </a:solidFill>
+            <a:prstDash val="solid"/>
+          </a:ln>
+        </p:spPr>
+      </p:sp>
+      <p:sp>
+        <p:nvSpPr>
+          <p:cNvPr id="29" name="Shape 27"/>
+          <p:cNvSpPr/>
+          <p:nvPr/>
+        </p:nvSpPr>
+        <p:spPr>
+          <a:xfrm>
+            <a:off x="9628632" y="4256532"/>
+            <a:ext cx="91440" cy="91440"/>
+          </a:xfrm>
+          <a:prstGeom prst="octagon">
+            <a:avLst/>
+          </a:prstGeom>
+          <a:solidFill>
+            <a:srgbClr val="C7443A"/>
+          </a:solidFill>
+          <a:ln w="12700">
+            <a:solidFill>
+              <a:srgbClr val="333333"/>
+            </a:solidFill>
+            <a:prstDash val="solid"/>
+          </a:ln>
+        </p:spPr>
+      </p:sp>
+      <p:sp>
+        <p:nvSpPr>
+          <p:cNvPr id="30" name="Text 28"/>
+          <p:cNvSpPr/>
+          <p:nvPr/>
+        </p:nvSpPr>
+        <p:spPr>
+          <a:xfrm>
+            <a:off x="9774936" y="4206240"/>
+            <a:ext cx="1700784" cy="192024"/>
+          </a:xfrm>
+          <a:prstGeom prst="rect">
+            <a:avLst/>
+          </a:prstGeom>
+          <a:noFill/>
+          <a:ln/>
+        </p:spPr>
+        <p:txBody>
+          <a:bodyPr wrap="square" lIns="0" tIns="0" rIns="0" bIns="0" rtlCol="0" anchor="ctr"/>
+          <a:lstStyle/>
+          <a:p>
+            <a:pPr indent="0" marL="0">
+              <a:buNone/>
+            </a:pPr>
+            <a:r>
+              <a:rPr lang="en-US" sz="750" b="1" spc="20" kern="0" dirty="0">
+                <a:solidFill>
+                  <a:srgbClr val="C8A951"/>
+                </a:solidFill>
+                <a:latin typeface="Calibri" pitchFamily="34" charset="0"/>
+                <a:ea typeface="Calibri" pitchFamily="34" charset="-122"/>
+                <a:cs typeface="Calibri" pitchFamily="34" charset="-120"/>
+              </a:rPr>
+              <a:t>/breaker endpoint in prototype</a:t>
+            </a:r>
+            <a:endParaRPr lang="en-US" sz="750" dirty="0"/>
+          </a:p>
+        </p:txBody>
+      </p:sp>
+      <p:sp>
+        <p:nvSpPr>
+          <p:cNvPr id="31" name="Shape 29"/>
+          <p:cNvSpPr/>
+          <p:nvPr/>
+        </p:nvSpPr>
+        <p:spPr>
+          <a:xfrm>
             <a:off x="640080" y="4553712"/>
             <a:ext cx="10908792" cy="731520"/>
           </a:xfrm>
@@ -8853,7 +8946,7 @@
       </p:sp>
       <p:sp>
         <p:nvSpPr>
-          <p:cNvPr id="29" name="Shape 27"/>
+          <p:cNvPr id="32" name="Shape 30"/>
           <p:cNvSpPr/>
           <p:nvPr/>
         </p:nvSpPr>
@@ -8878,7 +8971,7 @@
       </p:sp>
       <p:sp>
         <p:nvSpPr>
-          <p:cNvPr id="30" name="Shape 28"/>
+          <p:cNvPr id="33" name="Shape 31"/>
           <p:cNvSpPr/>
           <p:nvPr/>
         </p:nvSpPr>
@@ -8901,7 +8994,7 @@
       </p:sp>
       <p:sp>
         <p:nvSpPr>
-          <p:cNvPr id="31" name="Shape 29"/>
+          <p:cNvPr id="34" name="Shape 32"/>
           <p:cNvSpPr/>
           <p:nvPr/>
         </p:nvSpPr>
@@ -8924,7 +9017,7 @@
       </p:sp>
       <p:sp>
         <p:nvSpPr>
-          <p:cNvPr id="32" name="Text 30"/>
+          <p:cNvPr id="35" name="Text 33"/>
           <p:cNvSpPr/>
           <p:nvPr/>
         </p:nvSpPr>
@@ -8966,7 +9059,7 @@
       </p:sp>
       <p:sp>
         <p:nvSpPr>
-          <p:cNvPr id="33" name="Text 31"/>
+          <p:cNvPr id="36" name="Text 34"/>
           <p:cNvSpPr/>
           <p:nvPr/>
         </p:nvSpPr>
@@ -9008,7 +9101,7 @@
       </p:sp>
       <p:sp>
         <p:nvSpPr>
-          <p:cNvPr id="34" name="Text 32"/>
+          <p:cNvPr id="37" name="Text 35"/>
           <p:cNvSpPr/>
           <p:nvPr/>
         </p:nvSpPr>
@@ -9050,7 +9143,7 @@
       </p:sp>
       <p:sp>
         <p:nvSpPr>
-          <p:cNvPr id="35" name="Shape 33"/>
+          <p:cNvPr id="38" name="Shape 36"/>
           <p:cNvSpPr/>
           <p:nvPr/>
         </p:nvSpPr>
@@ -9077,7 +9170,7 @@
       </p:sp>
       <p:sp>
         <p:nvSpPr>
-          <p:cNvPr id="36" name="Shape 34"/>
+          <p:cNvPr id="39" name="Shape 37"/>
           <p:cNvSpPr/>
           <p:nvPr/>
         </p:nvSpPr>
@@ -9102,7 +9195,7 @@
       </p:sp>
       <p:sp>
         <p:nvSpPr>
-          <p:cNvPr id="37" name="Shape 35"/>
+          <p:cNvPr id="40" name="Shape 38"/>
           <p:cNvSpPr/>
           <p:nvPr/>
         </p:nvSpPr>
@@ -9125,7 +9218,7 @@
       </p:sp>
       <p:sp>
         <p:nvSpPr>
-          <p:cNvPr id="38" name="Shape 36"/>
+          <p:cNvPr id="41" name="Shape 39"/>
           <p:cNvSpPr/>
           <p:nvPr/>
         </p:nvSpPr>
@@ -9148,7 +9241,7 @@
       </p:sp>
       <p:sp>
         <p:nvSpPr>
-          <p:cNvPr id="39" name="Text 37"/>
+          <p:cNvPr id="42" name="Text 40"/>
           <p:cNvSpPr/>
           <p:nvPr/>
         </p:nvSpPr>
@@ -9190,7 +9283,7 @@
       </p:sp>
       <p:sp>
         <p:nvSpPr>
-          <p:cNvPr id="40" name="Text 38"/>
+          <p:cNvPr id="43" name="Text 41"/>
           <p:cNvSpPr/>
           <p:nvPr/>
         </p:nvSpPr>
@@ -9232,7 +9325,7 @@
       </p:sp>
       <p:sp>
         <p:nvSpPr>
-          <p:cNvPr id="41" name="Text 39"/>
+          <p:cNvPr id="44" name="Text 42"/>
           <p:cNvSpPr/>
           <p:nvPr/>
         </p:nvSpPr>
@@ -9274,7 +9367,7 @@
       </p:sp>
       <p:sp>
         <p:nvSpPr>
-          <p:cNvPr id="42" name="Text 40"/>
+          <p:cNvPr id="45" name="Text 43"/>
           <p:cNvSpPr/>
           <p:nvPr/>
         </p:nvSpPr>
@@ -9313,7 +9406,7 @@
       </p:sp>
       <p:sp>
         <p:nvSpPr>
-          <p:cNvPr id="43" name="Text 41"/>
+          <p:cNvPr id="46" name="Text 44"/>
           <p:cNvSpPr/>
           <p:nvPr/>
         </p:nvSpPr>

</xml_diff>